<commit_message>
deck: narrative v2, USAFacts credited, two counts corrected (task 2026-09-23_brief_narrative_v2)
Title section and four ## sections of docs/deck/brief_narrative.md replaced whole by the task's
§Replacements; every other section byte-identical to f0dd9dc. Chapter 0 stays 10 slides, deck 77.
Protected-deck check moves to base 3f0d0e7 and diffs the narrative against f0dd9dc + §Replacements.

Co-Authored-By: Claude Opus 5.5 (1M context) <noreply@anthropic.com>
</commit_message>
<xml_diff>
--- a/docs/deck/brief_deck.pptx
+++ b/docs/deck/brief_deck.pptx
@@ -578,7 +578,7 @@
           <a:lstStyle/>
           <a:p>
             <a:r>
-              <a:t>The framework in this brief is a set of 49 tests that ask one question of a statistical agency's website: when an AI system reads it, what does it get? The tests were built by operationalizing the USAFacts criteria for AI-ready government data, grounded in 264 admitted documents, and run against 13 federal statistical bodies on one scan cycle. census.gov is the first body to read its own result. This paper makes the case in the order of the argument; the chapters that follow hold the record in the order of the framework.</a:t>
+              <a:t>USAFacts published a framework to help government agencies decide how to make their data ready for AI. This brief describes what it took to run that framework as a measurement: a test for each of 49 indicators, three criteria the framework needed and did not have, a corpus of 264 admitted documents behind the indicators, and a graph that ties every result to an action an agency can take. The measurement was run against the federal statistical bodies on one scan cycle, 16 on the cycle and 13 ranked, and census.gov is the first body to read its own result. This paper makes the case in the order of the argument; the chapters that follow hold the record in the order of the framework.</a:t>
             </a:r>
           </a:p>
         </p:txBody>
@@ -718,7 +718,7 @@
           <a:lstStyle/>
           <a:p>
             <a:r>
-              <a:t>USAFacts' guide gives government agencies seven criteria for AI-ready data. Four of them, A through D, describe what a publisher must put on the public surface: accessible, documented, licensed and cataloged, in the agency's own words. Those criteria are written for a human program manager reading a page. They are not written for a test that runs against a URL and returns a verdict, and USAFacts did not supply indicator-level tests beneath them [B]. So the criteria could be endorsed and could not be applied. That is the gap this project closes: a shared measurement, run the same way against every body, that a publisher can rerun on its own product before anyone else does.</a:t>
+              <a:t>USAFacts did the hard first part: they looked at what AI systems need from public data and wrote it down as criteria an agency can read and agree with. Four of the criteria, A through D, describe the public surface a publisher controls: accessible, documented, licensed and cataloged. That framework is a decision aid, and it works as one. What it does not contain is a test per indicator, and the record says so plainly [B]. Without tests, an agency can endorse the framework and still not know which of its products fails, on which criterion, and for what reason. That is the gap this project set out to close, and it closed it by building on USAFacts' criteria rather than replacing them: a rule for every indicator that has one, the criteria for evaluation, release and governance that a running measurement turned out to need, and a graph in which each failing test points at a ranked action with an effort band. The graph is also served to an assistant over MCP, so the questions this brief asks of the record can be asked in plain language by someone who has never read a rule [D]. Little of the material is original. The corpus is 264 documents [C], the fields the rules read are standards other bodies wrote, and the scoring default is the OECD/JRC Handbook's [H]. The contribution is the join, and the fact that it runs.</a:t>
             </a:r>
           </a:p>
         </p:txBody>
@@ -788,7 +788,7 @@
           <a:lstStyle/>
           <a:p>
             <a:r>
-              <a:t>The cycle of record is `scan_2026-09-10_rj4`. Census ranks 5 of 13 on the hierarchical score and 5 on the flat score, and that rank rests on one leg: 1 pass of 1 judged row on A10, the deep-link test. Were that verdict reversed the body would rank 9 [G]. The ranking is therefore not the finding. The finding is in the reasons column. census.gov serves a public data catalog at data.json with 1805 records, and the catalog holds no record for the flagship products the harness probed. Because there is no record, there is no data dictionary link, no quality or revision metadata, no source lineage, no bureau and program code, and no inventory entry: B1, B4, D3, D4 and G4 all fail for the same absence [G]. The cheapest actions in the prescription table are in the hours band at no cost, and two of them, on F4 and G4, each carry an upper-bound delta of 0.2 [G]. A single catalog record with the fields the harness reads would move more legs than any other action the agency could take.</a:t>
+              <a:t>The cycle of record is `scan_2026-09-10_rj4`. The judged rows are leg by surface, and Census fails 34 of 39 [G]. It ranks 5 of 13 on the hierarchical score and 5 on the flat score, and that rank rests on one leg: 1 pass of 1 judged row on A10, the deep-link test. Were that verdict reversed the body would rank 9 [G]. The ranking is therefore not the finding. The finding is in the reasons column. census.gov serves a public data catalog at data.json with 1805 records, and the catalog holds no record for the flagship products the harness probed. Because there is no record, there is no data dictionary link, no quality or revision metadata, no source lineage, no bureau and program code, and no inventory entry: B1, B4, D3, D4 and G4 all fail for the same absence [G]. This is what the framework is for as a diagnostic. The prescription table lists, for each failing leg, the action, its effort band, and an upper bound on what it would move; the cheapest actions are in the hours band at no cost, and two of them, on F4 and G4, each carry a delta of 0.2 [G]. A single catalog record with the fields the harness reads would move more legs than any other action the agency could take.</a:t>
             </a:r>
           </a:p>
         </p:txBody>
@@ -858,7 +858,7 @@
           <a:lstStyle/>
           <a:p>
             <a:r>
-              <a:t>The delta page states the derivation rules and applies them to every indicator, so the reader can see what was kept, what was operationalized and what was added [B]. The verbatim test was run against the three USAFacts documents in the corpus with the same grounding normalizer every other span in the record uses, and no indicator's construct or text grounds in them: USAFacts named criteria, and every indicator is this project's operationalization of one. Three criteria, E evaluation, F release and G governance, have no USAFacts counterpart and are marked added. Where an indicator departs from what USAFacts intended, the departure is quoted, not smoothed over. The page ends with the items this project would hand back to USAFacts as feedback on their guide [B].</a:t>
+              <a:t>The delta page states the derivation rules and applies them to every indicator, so a reader can see what was kept, what was operationalized and what was added [B]. The verbatim test was run against the three USAFacts documents in the corpus with the same grounding normalizer every other span in the record uses, and no indicator's construct or text grounds in them. That is the expected result, not a finding against the guide: USAFacts named criteria, and each indicator is this project's operationalization of one [B]. Three criteria, E evaluation, F release and G governance, have no USAFacts counterpart and are marked added. Where an indicator departs from what USAFacts intended, the departure is quoted, not smoothed over [B]. The page ends with the items this project would hand back to USAFacts as feedback on their guide, in the spirit of a framework they published for others to build on [B].</a:t>
             </a:r>
           </a:p>
         </p:txBody>
@@ -8088,7 +8088,7 @@
                   <a:srgbClr val="000000"/>
                 </a:solidFill>
               </a:rPr>
-              <a:t>The problem is measurable, and nobody was measuring it</a:t>
+              <a:t>USAFacts built the framework; running it needed tests</a:t>
             </a:r>
           </a:p>
         </p:txBody>
@@ -8121,7 +8121,7 @@
                   <a:srgbClr val="555555"/>
                 </a:solidFill>
               </a:rPr>
-              <a:t>see chapter B · docs/deck/brief_narrative.md</a:t>
+              <a:t>see chapters G, B, D, C, H · docs/deck/brief_narrative.md</a:t>
             </a:r>
           </a:p>
         </p:txBody>
@@ -8155,7 +8155,7 @@
                   <a:srgbClr val="000000"/>
                 </a:solidFill>
               </a:rPr>
-              <a:t>AI systems now answer questions about federal statistics from what agency websites serve to a crawler.</a:t>
+              <a:t>USAFacts' guide gives agencies 7 criteria for AI-ready data, written for the people who decide what to publish.</a:t>
             </a:r>
           </a:p>
           <a:p>
@@ -8166,7 +8166,7 @@
                   <a:srgbClr val="000000"/>
                 </a:solidFill>
               </a:rPr>
-              <a:t>USAFacts published criteria for AI-ready government data. They are criteria, not tests.</a:t>
+              <a:t>A criterion says what good looks like. Acting on it needs a test that names which product falls short, why, and what to change first.</a:t>
             </a:r>
           </a:p>
           <a:p>
@@ -8177,7 +8177,7 @@
                   <a:srgbClr val="000000"/>
                 </a:solidFill>
               </a:rPr>
-              <a:t>An agency cannot improve what it cannot measure, and cannot compare itself with peers without a shared instrument.</a:t>
+              <a:t>This project keeps the criteria and adds the tests, the criteria the guide did not cover, and the graph from each result to an action.</a:t>
             </a:r>
           </a:p>
         </p:txBody>
@@ -10456,7 +10456,7 @@
                   <a:srgbClr val="000000"/>
                 </a:solidFill>
               </a:rPr>
-              <a:t>On the cycle of record, census.gov fails 34 of the 39 legs judged.</a:t>
+              <a:t>On the cycle of record, census.gov fails 34 of the 39 judged rows.</a:t>
             </a:r>
           </a:p>
           <a:p>
@@ -10478,7 +10478,7 @@
                   <a:srgbClr val="000000"/>
                 </a:solidFill>
               </a:rPr>
-              <a:t>One cause runs through most of the failures: the product is not in the catalog census.gov already serves.</a:t>
+              <a:t>One absence runs through most of the failures: the product is not in the catalog census.gov already serves.</a:t>
             </a:r>
           </a:p>
         </p:txBody>
@@ -13040,7 +13040,7 @@
                   <a:srgbClr val="000000"/>
                 </a:solidFill>
               </a:rPr>
-              <a:t>What we measured against, and how it differs from USAFacts</a:t>
+              <a:t>How the indicators relate to USAFacts' criteria</a:t>
             </a:r>
           </a:p>
         </p:txBody>
@@ -13107,7 +13107,7 @@
                   <a:srgbClr val="000000"/>
                 </a:solidFill>
               </a:rPr>
-              <a:t>49 indicators under 7 criteria; USAFacts' A to D kept, E to G added.</a:t>
+              <a:t>49 indicators under 7 criteria; A to D are USAFacts' criteria, E to G are added.</a:t>
             </a:r>
           </a:p>
           <a:p>
@@ -13118,7 +13118,7 @@
                   <a:srgbClr val="000000"/>
                 </a:solidFill>
               </a:rPr>
-              <a:t>0 of the 49 are USAFacts' words: 27 restated, 22 under added criteria.</a:t>
+              <a:t>Every indicator operationalizes a criterion. None repeats the guide's text, because the guide wrote criteria, not tests: 27 restated, 22 under added criteria, 0 verbatim.</a:t>
             </a:r>
           </a:p>
           <a:p>
@@ -13129,7 +13129,7 @@
                   <a:srgbClr val="000000"/>
                 </a:solidFill>
               </a:rPr>
-              <a:t>24 indicators have a current rule; 5 record a departure from USAFacts' intent, quoted.</a:t>
+              <a:t>24 indicators have a current rule; 5 record a departure from USAFacts' intent, quoted; the items in §8 go back to USAFacts as feedback.</a:t>
             </a:r>
           </a:p>
         </p:txBody>
@@ -18974,7 +18974,7 @@
                   <a:srgbClr val="000000"/>
                 </a:solidFill>
               </a:rPr>
-              <a:t>13 bodies scanned on one cycle: 23 legs judged, 1,009 findings.</a:t>
+              <a:t>16 bodies on the cycle, 13 ranked: 23 legs judged, 1,009 findings.</a:t>
             </a:r>
           </a:p>
           <a:p>

</xml_diff>

<commit_message>
deck: narrative v3, criterion labels from page B, the guide's own word, a label gate (task 2026-09-24_brief_narrative_v3)
Decision 2 sentence edits (G labelled with page B's 'FSS-derived constructs'); the p. 2
quotation as its own paragraph; tests/test_brief_deck.py gains a label and USAFacts-count
gate with the three v2 errors as negative controls. brief_appendix.pptx and line 1 of
brief_deck_content.md move only by the pack commit they stamp.

Co-Authored-By: Claude Opus 5.5 (1M context) <noreply@anthropic.com>
</commit_message>
<xml_diff>
--- a/docs/deck/brief_deck.pptx
+++ b/docs/deck/brief_deck.pptx
@@ -578,7 +578,7 @@
           <a:lstStyle/>
           <a:p>
             <a:r>
-              <a:t>USAFacts published a framework to help government agencies decide how to make their data ready for AI. This brief describes what it took to run that framework as a measurement: a test for each of 49 indicators, three criteria the framework needed and did not have, a corpus of 264 admitted documents behind the indicators, and a graph that ties every result to an action an agency can take. The measurement was run against the federal statistical bodies on one scan cycle, 16 on the cycle and 13 ranked, and census.gov is the first body to read its own result. This paper makes the case in the order of the argument; the chapters that follow hold the record in the order of the framework.</a:t>
+              <a:t>USAFacts published a framework to help government agencies decide how to make their data ready for AI. This brief describes what it took to run that framework as a measurement: 49 indicators written as tests, 24 of them with a rule that runs today, three criteria the framework needed and did not have, a corpus of 264 admitted documents behind the indicators, and a graph that ties every result to an action an agency can take. The measurement was run against the federal statistical bodies on one scan cycle, 16 on the cycle and 13 ranked, and census.gov is the first body to read its own result. This paper makes the case in the order of the argument; the chapters that follow hold the record in the order of the framework.</a:t>
             </a:r>
           </a:p>
         </p:txBody>
@@ -718,7 +718,13 @@
           <a:lstStyle/>
           <a:p>
             <a:r>
-              <a:t>USAFacts did the hard first part: they looked at what AI systems need from public data and wrote it down as criteria an agency can read and agree with. Four of the criteria, A through D, describe the public surface a publisher controls: accessible, documented, licensed and cataloged. That framework is a decision aid, and it works as one. What it does not contain is a test per indicator, and the record says so plainly [B]. Without tests, an agency can endorse the framework and still not know which of its products fails, on which criterion, and for what reason. That is the gap this project set out to close, and it closed it by building on USAFacts' criteria rather than replacing them: a rule for every indicator that has one, the criteria for evaluation, release and governance that a running measurement turned out to need, and a graph in which each failing test points at a ranked action with an effort band. The graph is also served to an assistant over MCP, so the questions this brief asks of the record can be asked in plain language by someone who has never read a rule [D]. Little of the material is original. The corpus is 264 documents [C], the fields the rules read are standards other bodies wrote, and the scoring default is the OECD/JRC Handbook's [H]. The contribution is the join, and the fact that it runs.</a:t>
+              <a:t>USAFacts did the hard first part: they looked at what AI systems need from public data and wrote it down as criteria an agency can read and agree with. The guide calls itself a roadmap, and its four criteria, A through D, are accessible, understandable, accurate and open [B]. That framework is a decision aid, and it works as one. What it does not contain is a test per indicator, and the record says so plainly [B]. Without tests, an agency can endorse the framework and still not know which of its products fails, on which criterion, and for what reason. That is the gap this project set out to close, and it closed it by building on USAFacts' criteria rather than replacing them: a rule for every indicator that has one, the three criteria a running measurement turned out to need, E the TEVV loop, F release engineering and G the FSS-derived constructs, and a graph in which each failing test points at a ranked action with an effort band. The graph is also served to an assistant over MCP, so the questions this brief asks of the record can be asked in plain language by someone who has never read a rule [D]. Little of the material is original. The corpus is 264 documents [C], the fields the rules read are standards other bodies wrote, and the scoring default is the OECD/JRC Handbook's [H]. The contribution is the join, and the fact that it runs.</a:t>
+            </a:r>
+          </a:p>
+          <a:p/>
+          <a:p>
+            <a:r>
+              <a:t>&gt; As government continues to evolve its role as a data provider to AI systems, these criteria should provide a roadmap for allowing AI to not only access, but also understand and validate the data they are retrieving and presenting to users. [B]</a:t>
             </a:r>
           </a:p>
         </p:txBody>
@@ -858,7 +864,7 @@
           <a:lstStyle/>
           <a:p>
             <a:r>
-              <a:t>The delta page states the derivation rules and applies them to every indicator, so a reader can see what was kept, what was operationalized and what was added [B]. The verbatim test was run against the three USAFacts documents in the corpus with the same grounding normalizer every other span in the record uses, and no indicator's construct or text grounds in them. That is the expected result, not a finding against the guide: USAFacts named criteria, and each indicator is this project's operationalization of one [B]. Three criteria, E evaluation, F release and G governance, have no USAFacts counterpart and are marked added. Where an indicator departs from what USAFacts intended, the departure is quoted, not smoothed over [B]. The page ends with the items this project would hand back to USAFacts as feedback on their guide, in the spirit of a framework they published for others to build on [B].</a:t>
+              <a:t>The delta page states the derivation rules and applies them to every indicator, so a reader can see what was kept, what was operationalized and what was added [B]. The verbatim test was run against the three USAFacts documents in the corpus with the same grounding normalizer every other span in the record uses, and no indicator's construct or text grounds in them. That is the expected result, not a finding against the guide: USAFacts named criteria, and each indicator is this project's operationalization of one [B]. Three criteria, E the TEVV loop, F release engineering and G the FSS-derived constructs, have no USAFacts counterpart and are marked added [B]. Where an indicator departs from what USAFacts intended, the departure is quoted, not smoothed over [B]. The page ends with the items this project would hand back to USAFacts as feedback on their guide, in the spirit of a framework they published for others to build on [B].</a:t>
             </a:r>
           </a:p>
         </p:txBody>
@@ -4285,7 +4291,7 @@
                   <a:srgbClr val="000000"/>
                 </a:solidFill>
               </a:rPr>
-              <a:t>2026-09-23 · pack commit ed2b3c205588 · cycle of record scan_2026-09-10_rj4</a:t>
+              <a:t>2026-09-24 · pack commit 12d578c3a02b · cycle of record scan_2026-09-10_rj4</a:t>
             </a:r>
           </a:p>
         </p:txBody>
@@ -5006,7 +5012,7 @@
                   <a:srgbClr val="000000"/>
                 </a:solidFill>
               </a:rPr>
-              <a:t>Pack: docs/brief/ at commit ed2b3c205588 (2026-09-23), written by scripts/build_brief_pack.py and by nothing else</a:t>
+              <a:t>Pack: docs/brief/ at commit 12d578c3a02b (2026-09-24), written by scripts/build_brief_pack.py and by nothing else</a:t>
             </a:r>
           </a:p>
           <a:p>
@@ -8121,7 +8127,7 @@
                   <a:srgbClr val="555555"/>
                 </a:solidFill>
               </a:rPr>
-              <a:t>see chapters G, B, D, C, H · docs/deck/brief_narrative.md</a:t>
+              <a:t>see chapters B, D, C, H · docs/deck/brief_narrative.md</a:t>
             </a:r>
           </a:p>
         </p:txBody>
@@ -8155,7 +8161,7 @@
                   <a:srgbClr val="000000"/>
                 </a:solidFill>
               </a:rPr>
-              <a:t>USAFacts' guide gives agencies 7 criteria for AI-ready data, written for the people who decide what to publish.</a:t>
+              <a:t>USAFacts' guide gives agencies four criteria for AI-ready data, accessible, understandable, accurate and open, written for the people who decide what to publish.</a:t>
             </a:r>
           </a:p>
           <a:p>
@@ -13107,7 +13113,7 @@
                   <a:srgbClr val="000000"/>
                 </a:solidFill>
               </a:rPr>
-              <a:t>49 indicators under 7 criteria; A to D are USAFacts' criteria, E to G are added.</a:t>
+              <a:t>49 indicators under 7 criteria; A to D are USAFacts' four, E to G are added.</a:t>
             </a:r>
           </a:p>
           <a:p>
@@ -18716,7 +18722,7 @@
                   <a:srgbClr val="000000"/>
                 </a:solidFill>
               </a:rPr>
-              <a:t>docs/deck/brief_appendix.pptx: 219 slides · 2026-09-23 · pack commit ed2b3c205588 · cycle of record scan_2026-09-10_rj4</a:t>
+              <a:t>docs/deck/brief_appendix.pptx: 219 slides · 2026-09-24 · pack commit 12d578c3a02b · cycle of record scan_2026-09-10_rj4</a:t>
             </a:r>
           </a:p>
         </p:txBody>

</xml_diff>

<commit_message>
narrative v4: three claims closed against pages B, G and H; deck re-rendered; protected check moves to this launch (task 2026-09-24_brief_narrative_v4, decisions 3 and 4)
Co-Authored-By: Claude Opus 5.5 (1M context) <noreply@anthropic.com>
</commit_message>
<xml_diff>
--- a/docs/deck/brief_deck.pptx
+++ b/docs/deck/brief_deck.pptx
@@ -578,7 +578,7 @@
           <a:lstStyle/>
           <a:p>
             <a:r>
-              <a:t>USAFacts published a framework to help government agencies decide how to make their data ready for AI. This brief describes what it took to run that framework as a measurement: 49 indicators written as tests, 24 of them with a rule that runs today, three criteria the framework needed and did not have, a corpus of 264 admitted documents behind the indicators, and a graph that ties every result to an action an agency can take. The measurement was run against the federal statistical bodies on one scan cycle, 16 on the cycle and 13 ranked, and census.gov is the first body to read its own result. This paper makes the case in the order of the argument; the chapters that follow hold the record in the order of the framework.</a:t>
+              <a:t>USAFacts published a framework to help government agencies decide how to make their data ready for AI. This brief describes what it took to run that framework as a measurement: 49 indicators written as tests, 24 of them with a current rule in the registry, three criteria the framework needed and did not have, a corpus of 264 admitted documents behind the indicators, and a graph that ties every result to an action an agency can take. The measurement was run against the federal statistical bodies on one scan cycle, 16 on the cycle and 13 ranked, and census.gov is the first body to read its own result. This paper makes the case in the order of the argument; the chapters that follow hold the record in the order of the framework.</a:t>
             </a:r>
           </a:p>
         </p:txBody>
@@ -4291,7 +4291,7 @@
                   <a:srgbClr val="000000"/>
                 </a:solidFill>
               </a:rPr>
-              <a:t>2026-09-24 · pack commit 12d578c3a02b · cycle of record scan_2026-09-10_rj4</a:t>
+              <a:t>2026-09-24 · pack commit e7690476176e · cycle of record scan_2026-09-10_rj4</a:t>
             </a:r>
           </a:p>
         </p:txBody>
@@ -4409,7 +4409,7 @@
                   <a:srgbClr val="000000"/>
                 </a:solidFill>
               </a:rPr>
-              <a:t>16 of 48 framework indicators are measured; 8 have a harness built; 24 are specified only.</a:t>
+              <a:t>Of the 48 indicators in the framework record, 16 are measured, 8 have a harness built and 24 are specified only; the record's 49th indicator node, A12, is a candidate whose promotion is an operator decision.</a:t>
             </a:r>
           </a:p>
           <a:p>
@@ -4431,7 +4431,7 @@
                   <a:srgbClr val="000000"/>
                 </a:solidFill>
               </a:rPr>
-              <a:t>The evaluation criteria, C and E, are largely unmeasured: they need benchmark sets this project has not built.</a:t>
+              <a:t>Two criteria, C accurate and E the TEVV loop, are largely unmeasured: the requirements table says what would unlock them, and it is benchmark sets this project has not built and agency records the publisher holds.</a:t>
             </a:r>
           </a:p>
         </p:txBody>
@@ -5012,7 +5012,7 @@
                   <a:srgbClr val="000000"/>
                 </a:solidFill>
               </a:rPr>
-              <a:t>Pack: docs/brief/ at commit 12d578c3a02b (2026-09-24), written by scripts/build_brief_pack.py and by nothing else</a:t>
+              <a:t>Pack: docs/brief/ at commit e7690476176e (2026-09-24), written by scripts/build_brief_pack.py and by nothing else</a:t>
             </a:r>
           </a:p>
           <a:p>
@@ -18722,7 +18722,7 @@
                   <a:srgbClr val="000000"/>
                 </a:solidFill>
               </a:rPr>
-              <a:t>docs/deck/brief_appendix.pptx: 219 slides · 2026-09-24 · pack commit 12d578c3a02b · cycle of record scan_2026-09-10_rj4</a:t>
+              <a:t>docs/deck/brief_appendix.pptx: 219 slides · 2026-09-24 · pack commit e7690476176e · cycle of record scan_2026-09-10_rj4</a:t>
             </a:r>
           </a:p>
         </p:txBody>

</xml_diff>